<commit_message>
docs: rebrand docs site
- Replace dinosaur mascot with flame-and-braces logo (SVG, favicon, social card)
- Switch theme from stock Docusaurus green to slate, with ember for CTAs and hero
- Redraw homepage illustrations with the new mark and palette
- Fix low-contrast white text on Workflow Wizard buttons in dark mode
- Refresh overview slides for current features and new branding
</commit_message>
<xml_diff>
--- a/docs-site/static/slides/GrillMyCode-slide.pptx
+++ b/docs-site/static/slides/GrillMyCode-slide.pptx
@@ -673,8 +673,8 @@
         </p:nvSpPr>
         <p:spPr>
           <a:xfrm>
-            <a:off x="365760" y="228600"/>
-            <a:ext cx="11430000" cy="594360"/>
+            <a:off x="1051560" y="228600"/>
+            <a:ext cx="10744200" cy="594360"/>
           </a:xfrm>
           <a:prstGeom prst="rect">
             <a:avLst/>
@@ -698,7 +698,7 @@
                 <a:ea typeface="Calibri" pitchFamily="34" charset="-122"/>
                 <a:cs typeface="Calibri" pitchFamily="34" charset="-120"/>
               </a:rPr>
-              <a:t>🔥 GrillMyCode</a:t>
+              <a:t>GrillMyCode</a:t>
             </a:r>
             <a:endParaRPr lang="en-US" sz="3200" dirty="0"/>
           </a:p>
@@ -888,7 +888,7 @@
                 <a:ea typeface="Calibri" pitchFamily="34" charset="-122"/>
                 <a:cs typeface="Calibri" pitchFamily="34" charset="-120"/>
               </a:rPr>
-              <a:t>3.  Sends the code to an AI provider to generate targeted questions</a:t>
+              <a:t>3.  Sends the code to OpenRouter to generate targeted questions</a:t>
             </a:r>
             <a:endParaRPr lang="en-US" sz="1400" dirty="0"/>
           </a:p>
@@ -908,7 +908,7 @@
                 <a:ea typeface="Calibri" pitchFamily="34" charset="-122"/>
                 <a:cs typeface="Calibri" pitchFamily="34" charset="-120"/>
               </a:rPr>
-              <a:t>4.  Delivers the assessment as a PR comment, Issue, or Discussion</a:t>
+              <a:t>4.  Delivers the assessment as a GitHub Issue and PDF</a:t>
             </a:r>
             <a:endParaRPr lang="en-US" sz="1400" dirty="0"/>
           </a:p>
@@ -989,7 +989,7 @@
                 <a:ea typeface="Calibri" pitchFamily="34" charset="-122"/>
                 <a:cs typeface="Calibri" pitchFamily="34" charset="-120"/>
               </a:rPr>
-              <a:t>✦  Zero student setup — triggers on every push, pull request, or manually</a:t>
+              <a:t>✦  Zero student setup — runs on every push, submission tag, or manually</a:t>
             </a:r>
             <a:endParaRPr lang="en-US" sz="1400" dirty="0"/>
           </a:p>
@@ -1009,7 +1009,7 @@
                 <a:ea typeface="Calibri" pitchFamily="34" charset="-122"/>
                 <a:cs typeface="Calibri" pitchFamily="34" charset="-120"/>
               </a:rPr>
-              <a:t>✦  Built for GitHub Classroom — skips template/starter files automatically</a:t>
+              <a:t>✦  Built for Classroom 50 — skips template/starter files automatically</a:t>
             </a:r>
             <a:endParaRPr lang="en-US" sz="1400" dirty="0"/>
           </a:p>
@@ -1029,7 +1029,7 @@
                 <a:ea typeface="Calibri" pitchFamily="34" charset="-122"/>
                 <a:cs typeface="Calibri" pitchFamily="34" charset="-120"/>
               </a:rPr>
-              <a:t>✦  Free by default — uses GitHub Models, </a:t>
+              <a:t>✦  Low cost — usually under a cent per run via </a:t>
             </a:r>
             <a:r>
               <a:rPr lang="en-US" sz="1400" dirty="0" err="1">
@@ -1051,7 +1051,7 @@
                 <a:ea typeface="Calibri" pitchFamily="34" charset="-122"/>
                 <a:cs typeface="Calibri" pitchFamily="34" charset="-120"/>
               </a:rPr>
-              <a:t>, etc.</a:t>
+              <a:t/>
             </a:r>
             <a:endParaRPr lang="en-US" sz="1400" dirty="0"/>
           </a:p>
@@ -1071,7 +1071,7 @@
                 <a:ea typeface="Calibri" pitchFamily="34" charset="-122"/>
                 <a:cs typeface="Calibri" pitchFamily="34" charset="-120"/>
               </a:rPr>
-              <a:t>✦  Configurable — questions, file filters, assignment context, AI provider</a:t>
+              <a:t>✦  Configurable — questions, file filters, assignment context, AI model</a:t>
             </a:r>
             <a:endParaRPr lang="en-US" sz="1400" dirty="0"/>
           </a:p>
@@ -1184,7 +1184,7 @@
                 <a:ea typeface="Courier New" pitchFamily="34" charset="-122"/>
                 <a:cs typeface="Courier New" pitchFamily="34" charset="-120"/>
               </a:rPr>
-              <a:t>name: Code Assessment</a:t>
+              <a:t>name: GrillMyCode</a:t>
             </a:r>
             <a:endParaRPr lang="en-US" sz="900" dirty="0"/>
           </a:p>
@@ -1224,7 +1224,7 @@
                 <a:ea typeface="Courier New" pitchFamily="34" charset="-122"/>
                 <a:cs typeface="Courier New" pitchFamily="34" charset="-120"/>
               </a:rPr>
-              <a:t>  pull_request:</a:t>
+              <a:t>  push:</a:t>
             </a:r>
             <a:endParaRPr lang="en-US" sz="900" dirty="0"/>
           </a:p>
@@ -1244,17 +1244,8 @@
                 <a:ea typeface="Courier New" pitchFamily="34" charset="-122"/>
                 <a:cs typeface="Courier New" pitchFamily="34" charset="-120"/>
               </a:rPr>
-              <a:t>    types: [opened, synchronize]</a:t>
-            </a:r>
-            <a:endParaRPr lang="en-US" sz="900" dirty="0"/>
-          </a:p>
-          <a:p>
-            <a:pPr marL="0" indent="0">
-              <a:lnSpc>
-                <a:spcPct val="125000"/>
-              </a:lnSpc>
-              <a:buNone/>
-            </a:pPr>
+              <a:t>    branches: ["main", "master"]</a:t>
+            </a:r>
             <a:endParaRPr lang="en-US" sz="900" dirty="0"/>
           </a:p>
           <a:p>
@@ -1273,8 +1264,17 @@
                 <a:ea typeface="Courier New" pitchFamily="34" charset="-122"/>
                 <a:cs typeface="Courier New" pitchFamily="34" charset="-120"/>
               </a:rPr>
-              <a:t>jobs:</a:t>
-            </a:r>
+              <a:t>  workflow_dispatch:</a:t>
+            </a:r>
+            <a:endParaRPr lang="en-US" sz="900" dirty="0"/>
+          </a:p>
+          <a:p>
+            <a:pPr marL="0" indent="0">
+              <a:lnSpc>
+                <a:spcPct val="125000"/>
+              </a:lnSpc>
+              <a:buNone/>
+            </a:pPr>
             <a:endParaRPr lang="en-US" sz="900" dirty="0"/>
           </a:p>
           <a:p>
@@ -1293,7 +1293,7 @@
                 <a:ea typeface="Courier New" pitchFamily="34" charset="-122"/>
                 <a:cs typeface="Courier New" pitchFamily="34" charset="-120"/>
               </a:rPr>
-              <a:t>  generate-questions:</a:t>
+              <a:t>jobs:</a:t>
             </a:r>
             <a:endParaRPr lang="en-US" sz="900" dirty="0"/>
           </a:p>
@@ -1313,7 +1313,7 @@
                 <a:ea typeface="Courier New" pitchFamily="34" charset="-122"/>
                 <a:cs typeface="Courier New" pitchFamily="34" charset="-120"/>
               </a:rPr>
-              <a:t>    runs-on: ubuntu-latest</a:t>
+              <a:t>  generate-questions:</a:t>
             </a:r>
             <a:endParaRPr lang="en-US" sz="900" dirty="0"/>
           </a:p>
@@ -1333,7 +1333,7 @@
                 <a:ea typeface="Courier New" pitchFamily="34" charset="-122"/>
                 <a:cs typeface="Courier New" pitchFamily="34" charset="-120"/>
               </a:rPr>
-              <a:t>    permissions:</a:t>
+              <a:t>    runs-on: ubuntu-latest</a:t>
             </a:r>
             <a:endParaRPr lang="en-US" sz="900" dirty="0"/>
           </a:p>
@@ -1353,7 +1353,7 @@
                 <a:ea typeface="Courier New" pitchFamily="34" charset="-122"/>
                 <a:cs typeface="Courier New" pitchFamily="34" charset="-120"/>
               </a:rPr>
-              <a:t>      contents: read</a:t>
+              <a:t>    permissions:</a:t>
             </a:r>
             <a:endParaRPr lang="en-US" sz="900" dirty="0"/>
           </a:p>
@@ -1373,7 +1373,7 @@
                 <a:ea typeface="Courier New" pitchFamily="34" charset="-122"/>
                 <a:cs typeface="Courier New" pitchFamily="34" charset="-120"/>
               </a:rPr>
-              <a:t>      pull-requests: write</a:t>
+              <a:t>      contents: write</a:t>
             </a:r>
             <a:endParaRPr lang="en-US" sz="900" dirty="0"/>
           </a:p>
@@ -1393,7 +1393,7 @@
                 <a:ea typeface="Courier New" pitchFamily="34" charset="-122"/>
                 <a:cs typeface="Courier New" pitchFamily="34" charset="-120"/>
               </a:rPr>
-              <a:t>      models: read</a:t>
+              <a:t>      issues: write</a:t>
             </a:r>
             <a:endParaRPr lang="en-US" sz="900" dirty="0"/>
           </a:p>
@@ -1548,6 +1548,27 @@
                 <a:ea typeface="Courier New" pitchFamily="34" charset="-122"/>
                 <a:cs typeface="Courier New" pitchFamily="34" charset="-120"/>
               </a:rPr>
+              <a:t>          api_key: ${{ secrets.OPENROUTER_API_KEY }} # OpenRouter key (required)</a:t>
+            </a:r>
+            <a:br>
+              <a:rPr lang="en-US" sz="900" dirty="0">
+                <a:solidFill>
+                  <a:srgbClr val="94D2BD"/>
+                </a:solidFill>
+                <a:latin typeface="Courier New" pitchFamily="34" charset="0"/>
+                <a:ea typeface="Courier New" pitchFamily="34" charset="-122"/>
+                <a:cs typeface="Courier New" pitchFamily="34" charset="-120"/>
+              </a:rPr>
+            </a:br>
+            <a:r>
+              <a:rPr lang="en-US" sz="900" dirty="0">
+                <a:solidFill>
+                  <a:srgbClr val="94D2BD"/>
+                </a:solidFill>
+                <a:latin typeface="Courier New" pitchFamily="34" charset="0"/>
+                <a:ea typeface="Courier New" pitchFamily="34" charset="-122"/>
+                <a:cs typeface="Courier New" pitchFamily="34" charset="-120"/>
+              </a:rPr>
               <a:t>          </a:t>
             </a:r>
             <a:r>
@@ -1558,7 +1579,7 @@
                 <a:latin typeface="Courier New" panose="02070309020205020404" pitchFamily="49" charset="0"/>
                 <a:cs typeface="Courier New" panose="02070309020205020404" pitchFamily="49" charset="0"/>
               </a:rPr>
-              <a:t>num_questions: ‘20' # how many questions to generate</a:t>
+              <a:t>num_questions: '20' # how many questions to generate</a:t>
             </a:r>
             <a:br>
               <a:rPr lang="en-CA" sz="900" dirty="0">
@@ -1577,7 +1598,7 @@
                 <a:latin typeface="Courier New" panose="02070309020205020404" pitchFamily="49" charset="0"/>
                 <a:cs typeface="Courier New" panose="02070309020205020404" pitchFamily="49" charset="0"/>
               </a:rPr>
-              <a:t>          include_answers: ‘false' # attach model answers for instructor review</a:t>
+              <a:t>          include_answers: 'false' # true shows answers to students — leave off</a:t>
             </a:r>
           </a:p>
           <a:p>
@@ -1589,7 +1610,7 @@
                 <a:latin typeface="Courier New" panose="02070309020205020404" pitchFamily="49" charset="0"/>
                 <a:cs typeface="Courier New" panose="02070309020205020404" pitchFamily="49" charset="0"/>
               </a:rPr>
-              <a:t>          additional_context: | # tell the AI what the assignment is about</a:t>
+              <a:t>          instructor_context: | # tell the AI what the assignment is about</a:t>
             </a:r>
           </a:p>
           <a:p>
@@ -1626,18 +1647,6 @@
                 <a:cs typeface="Courier New" panose="02070309020205020404" pitchFamily="49" charset="0"/>
               </a:rPr>
               <a:t>          assignment_context: 'docs/brief.pdf' # inject the actual assignment into the prompt</a:t>
-            </a:r>
-          </a:p>
-          <a:p>
-            <a:r>
-              <a:rPr lang="en-CA" sz="900" dirty="0">
-                <a:solidFill>
-                  <a:srgbClr val="94D2BD"/>
-                </a:solidFill>
-                <a:latin typeface="Courier New" panose="02070309020205020404" pitchFamily="49" charset="0"/>
-                <a:cs typeface="Courier New" panose="02070309020205020404" pitchFamily="49" charset="0"/>
-              </a:rPr>
-              <a:t>          post_issue: 'true' # also create a GitHub Issue assigned to the student</a:t>
             </a:r>
           </a:p>
           <a:p>
@@ -1703,7 +1712,7 @@
                 <a:ea typeface="Calibri" pitchFamily="34" charset="-122"/>
                 <a:cs typeface="Calibri" pitchFamily="34" charset="-120"/>
               </a:rPr>
-              <a:t>nscc-itc-assessment.github.io/GrillMyCode</a:t>
+              <a:t>grillmycode.org</a:t>
             </a:r>
             <a:endParaRPr lang="en-US" sz="1000" dirty="0"/>
           </a:p>
@@ -1751,7 +1760,7 @@
                   <a:schemeClr val="bg1"/>
                 </a:solidFill>
               </a:rPr>
-              <a:t>nscc-itc-assessment.github.io</a:t>
+              <a:t>grillmycode.org</a:t>
             </a:r>
             <a:r>
               <a:rPr lang="en-US" dirty="0">
@@ -1767,7 +1776,7 @@
                   <a:schemeClr val="bg1"/>
                 </a:solidFill>
               </a:rPr>
-              <a:t>GrillMyCode</a:t>
+              <a:t/>
             </a:r>
             <a:r>
               <a:rPr lang="en-US" dirty="0">
@@ -1775,7 +1784,7 @@
                   <a:schemeClr val="bg1"/>
                 </a:solidFill>
               </a:rPr>
-              <a:t>/</a:t>
+              <a:t/>
             </a:r>
             <a:br>
               <a:rPr lang="en-US" dirty="0">
@@ -1947,6 +1956,30 @@
           </a:p>
         </p:txBody>
       </p:sp>
+      <p:pic>
+        <p:nvPicPr>
+          <p:cNvPr id="21" name="GrillMyCode logo" descr="GrillMyCode logo"/>
+          <p:cNvPicPr>
+            <a:picLocks noChangeAspect="1"/>
+          </p:cNvPicPr>
+          <p:nvPr/>
+        </p:nvPicPr>
+        <p:blipFill>
+          <a:blip r:embed="rIdGmcLogo"/>
+          <a:stretch>
+            <a:fillRect/>
+          </a:stretch>
+        </p:blipFill>
+        <p:spPr>
+          <a:xfrm>
+            <a:off x="365760" y="228600"/>
+            <a:ext cx="594360" cy="594360"/>
+          </a:xfrm>
+          <a:prstGeom prst="rect">
+            <a:avLst/>
+          </a:prstGeom>
+        </p:spPr>
+      </p:pic>
     </p:spTree>
   </p:cSld>
   <p:clrMapOvr>

</xml_diff>